<commit_message>
Tweak slides and README
</commit_message>
<xml_diff>
--- a/Docs/ACO_TSP_Solver_Defence.pptx
+++ b/Docs/ACO_TSP_Solver_Defence.pptx
@@ -7220,7 +7220,7 @@
                 <a:ea typeface="Calibri" pitchFamily="34" charset="-122"/>
                 <a:cs typeface="Calibri" pitchFamily="34" charset="-120"/>
               </a:rPr>
-              <a:t>A best-so-far curve alone proves nothing; the baseline and iteration-best do.</a:t>
+              <a:t>A best-so-far curve alone proves little; the baseline and iteration-best do.</a:t>
             </a:r>
             <a:endParaRPr lang="en-US" sz="1500" dirty="0"/>
           </a:p>
@@ -24746,7 +24746,7 @@
                 <a:ea typeface="Calibri" pitchFamily="34" charset="-122"/>
                 <a:cs typeface="Calibri" pitchFamily="34" charset="-120"/>
               </a:rPr>
-              <a:t>Every tour shown is the direct output of a live Ant System run over natID dense matrices — verified against exact optima.</a:t>
+              <a:t>Every tour shown is the direct output of a live Ant System run over natID dense matrices; the algorithm was verified against exact optima.</a:t>
             </a:r>
             <a:endParaRPr lang="en-US" sz="1900" dirty="0"/>
           </a:p>
@@ -27089,7 +27089,7 @@
                 <a:ea typeface="Calibri" pitchFamily="34" charset="-122"/>
                 <a:cs typeface="Calibri" pitchFamily="34" charset="-120"/>
               </a:rPr>
-              <a:t>Both matrices are </a:t>
+              <a:t>All three matrices are </a:t>
             </a:r>
             <a:pPr indent="0" marL="0">
               <a:buNone/>

</xml_diff>